<commit_message>
docs: update lecturer notes and teaching decks
</commit_message>
<xml_diff>
--- a/IUEA_Teaching_Plan/decks/CML3113_Week12_Mining_Petroleum.pptx
+++ b/IUEA_Teaching_Plan/decks/CML3113_Week12_Mining_Petroleum.pptx
@@ -725,7 +725,7 @@
           <a:lstStyle/>
           <a:p>
             <a:r>
-              <a:t>Choosing a model means comparing candidates fairly. We score three of them on the same validation rows, so the comparison is fair. The average guess has an error of 2.71 kWh/t. The straight line has 0.67. The tree has 1.18.</a:t>
+              <a:t>Choosing a model means comparing candidates fairly. We score three of them on the same validation rows, so the comparison is fair. The average guess has an error of 2.71 kWh/t. The straight line has 0.67. The tree has 1.20.</a:t>
             </a:r>
           </a:p>
           <a:p/>
@@ -10925,7 +10925,7 @@
                           </a:solidFill>
                           <a:latin typeface="Calibri"/>
                         </a:rPr>
-                        <a:t>1.18</a:t>
+                        <a:t>1.20</a:t>
                       </a:r>
                     </a:p>
                   </a:txBody>
@@ -19225,7 +19225,7 @@
                           </a:solidFill>
                           <a:latin typeface="Calibri"/>
                         </a:rPr>
-                        <a:t>1.18</a:t>
+                        <a:t>1.20</a:t>
                       </a:r>
                     </a:p>
                   </a:txBody>

</xml_diff>